<commit_message>
Agregar a Noe Guillermo Euan Herrera y nombrar en las diapositivas las piezas de la rubrica.
El equipo queda en cuatro integrantes y las laminas dicen cliente, servidor, archivo de configuracion y servicio en la nube.

Co-authored-by: Cursor <cursoragent@cursor.com>
</commit_message>
<xml_diff>
--- a/equipo4_aws_slides.pptx
+++ b/equipo4_aws_slides.pptx
@@ -1148,7 +1148,7 @@
           <a:lstStyle/>
           <a:p>
             <a:r>
-              <a:t>Decir que estas seis partes son el borrador de la exposición. El detalle está en el reporte. Tiempo: 40 segundos.</a:t>
+              <a:t>Estas seis partes son la exposición. Máximo 15 minutos. El detalle está en el reporte. El video no se reproduce completo. Tiempo: 25 segundos.</a:t>
             </a:r>
           </a:p>
         </p:txBody>
@@ -1288,7 +1288,7 @@
           <a:lstStyle/>
           <a:p>
             <a:r>
-              <a:t>Nombrar las cuatro piezas y decir que el resto del catálogo, más de 200 servicios, no hace falta para esta API. Tiempo: 50 segundos.</a:t>
+              <a:t>Estas son las cuatro piezas de la rúbrica. Cliente: quien hace POST /ingresos con el token. Servidor: la tarea de Fargate, ya no la laptop. Archivo de configuración: la definición de la tarea, con imagen, puerto y variables. Servicio en la nube: ECR, RDS, S3 e IAM. Las siguientes láminas abren cada servicio. Tiempo: 1 minuto.</a:t>
             </a:r>
           </a:p>
         </p:txBody>
@@ -4971,7 +4971,7 @@
         <p:spPr>
           <a:xfrm>
             <a:off x="685800" y="4709160"/>
-            <a:ext cx="10241280" cy="1051560"/>
+            <a:ext cx="10241280" cy="1389888"/>
           </a:xfrm>
           <a:prstGeom prst="rect">
             <a:avLst/>
@@ -5042,6 +5042,25 @@
                 <a:cs typeface="Calibri"/>
               </a:rPr>
               <a:t>Luis Enrique Ramos Díaz</a:t>
+            </a:r>
+          </a:p>
+          <a:p>
+            <a:pPr algn="l">
+              <a:spcBef>
+                <a:spcPts val="0"/>
+              </a:spcBef>
+              <a:spcAft>
+                <a:spcPts val="0"/>
+              </a:spcAft>
+            </a:pPr>
+            <a:r>
+              <a:rPr sz="1800" b="0" i="0">
+                <a:solidFill>
+                  <a:srgbClr val="E6EBF0"/>
+                </a:solidFill>
+                <a:latin typeface="Calibri"/>
+              </a:rPr>
+              <a:t>Noé Guillermo Euan Herrera</a:t>
             </a:r>
           </a:p>
         </p:txBody>
@@ -5054,7 +5073,7 @@
         </p:nvSpPr>
         <p:spPr>
           <a:xfrm>
-            <a:off x="685800" y="5943600"/>
+            <a:off x="685800" y="6199632"/>
             <a:ext cx="10241280" cy="365760"/>
           </a:xfrm>
           <a:prstGeom prst="rect">
@@ -11087,7 +11106,7 @@
                 <a:ea typeface="Calibri"/>
                 <a:cs typeface="Calibri"/>
               </a:rPr>
-              <a:t>Dónde corre, se guarda y se autoriza</a:t>
+              <a:t>Cliente, servidor y archivo</a:t>
             </a:r>
           </a:p>
         </p:txBody>
@@ -12440,7 +12459,7 @@
                 <a:ea typeface="Calibri"/>
                 <a:cs typeface="Calibri"/>
               </a:rPr>
-              <a:t>Con cuatro servicios basta</a:t>
+              <a:t>Cliente, servidor, archivo y servicio</a:t>
             </a:r>
           </a:p>
         </p:txBody>
@@ -12503,7 +12522,7 @@
                 <a:ea typeface="Calibri"/>
                 <a:cs typeface="Calibri"/>
               </a:rPr>
-              <a:t>01    Contenedor</a:t>
+              <a:t>01    Cliente</a:t>
             </a:r>
           </a:p>
           <a:p>
@@ -12524,7 +12543,7 @@
                 <a:ea typeface="Calibri"/>
                 <a:cs typeface="Calibri"/>
               </a:rPr>
-              <a:t>ECR guarda la imagen.</a:t>
+              <a:t>Quien llama la API.</a:t>
             </a:r>
           </a:p>
           <a:p>
@@ -12545,7 +12564,7 @@
                 <a:ea typeface="Calibri"/>
                 <a:cs typeface="Calibri"/>
               </a:rPr>
-              <a:t>Fargate la ejecuta.</a:t>
+              <a:t>Trae el token.</a:t>
             </a:r>
           </a:p>
         </p:txBody>
@@ -12608,7 +12627,7 @@
                 <a:ea typeface="Calibri"/>
                 <a:cs typeface="Calibri"/>
               </a:rPr>
-              <a:t>02    Base de datos</a:t>
+              <a:t>02    Servidor</a:t>
             </a:r>
           </a:p>
           <a:p>
@@ -12629,7 +12648,7 @@
                 <a:ea typeface="Calibri"/>
                 <a:cs typeface="Calibri"/>
               </a:rPr>
-              <a:t>RDS for MySQL.</a:t>
+              <a:t>La tarea en Fargate.</a:t>
             </a:r>
           </a:p>
           <a:p>
@@ -12650,7 +12669,7 @@
                 <a:ea typeface="Calibri"/>
                 <a:cs typeface="Calibri"/>
               </a:rPr>
-              <a:t>El mismo SQL de siempre.</a:t>
+              <a:t>Ya no es la laptop.</a:t>
             </a:r>
           </a:p>
         </p:txBody>
@@ -12713,7 +12732,7 @@
                 <a:ea typeface="Calibri"/>
                 <a:cs typeface="Calibri"/>
               </a:rPr>
-              <a:t>03    Archivos</a:t>
+              <a:t>03    Archivo</a:t>
             </a:r>
           </a:p>
           <a:p>
@@ -12734,7 +12753,7 @@
                 <a:ea typeface="Calibri"/>
                 <a:cs typeface="Calibri"/>
               </a:rPr>
-              <a:t>S3 guarda el PDF.</a:t>
+              <a:t>De configuración:</a:t>
             </a:r>
           </a:p>
           <a:p>
@@ -12755,7 +12774,7 @@
                 <a:ea typeface="Calibri"/>
                 <a:cs typeface="Calibri"/>
               </a:rPr>
-              <a:t>La fila guarda la clave.</a:t>
+              <a:t>imagen, puerto, variables.</a:t>
             </a:r>
           </a:p>
         </p:txBody>
@@ -12820,7 +12839,7 @@
                 <a:ea typeface="Calibri"/>
                 <a:cs typeface="Calibri"/>
               </a:rPr>
-              <a:t>04    Acceso</a:t>
+              <a:t>04    Servicio</a:t>
             </a:r>
           </a:p>
           <a:p>
@@ -12841,7 +12860,7 @@
                 <a:ea typeface="Calibri"/>
                 <a:cs typeface="Calibri"/>
               </a:rPr>
-              <a:t>IAM y la red privada.</a:t>
+              <a:t>En la nube:</a:t>
             </a:r>
           </a:p>
           <a:p>
@@ -12862,7 +12881,7 @@
                 <a:ea typeface="Calibri"/>
                 <a:cs typeface="Calibri"/>
               </a:rPr>
-              <a:t>El token sigue en la API.</a:t>
+              <a:t>ECR, RDS, S3 e IAM.</a:t>
             </a:r>
           </a:p>
         </p:txBody>
@@ -13626,7 +13645,7 @@
                 <a:ea typeface="Calibri"/>
                 <a:cs typeface="Calibri"/>
               </a:rPr>
-              <a:t>Para arrancar, Express Mode pide la imagen, un rol de ejecución</a:t>
+              <a:t>Eso se escribe en el archivo de configuración de la tarea.</a:t>
             </a:r>
           </a:p>
           <a:p>
@@ -13647,7 +13666,7 @@
                 <a:ea typeface="Calibri"/>
                 <a:cs typeface="Calibri"/>
               </a:rPr>
-              <a:t>y un rol de infraestructura. La API tiene que poder apagarse</a:t>
+              <a:t>Imagen, puerto, variables y roles.</a:t>
             </a:r>
           </a:p>
           <a:p>
@@ -13668,7 +13687,7 @@
                 <a:ea typeface="Calibri"/>
                 <a:cs typeface="Calibri"/>
               </a:rPr>
-              <a:t>sin perder datos: el estado no vive en el disco del contenedor.</a:t>
+              <a:t>Si la tarea se apaga, el estado sigue en RDS y en S3.</a:t>
             </a:r>
           </a:p>
         </p:txBody>

</xml_diff>